<commit_message>
ASX review: reconcile docs and deck with the typo fixes (PR #9)
- Log: O1 / O3-O6 / P9 -> FIXED IN PR (PR #9); D4 / D5 -> RESOLVED
  (superseded by P1 / P2); S2 -> CLOSING; D2 note records the removed
  Concept Mapping duplicates; new statuses CLOSING / FIXED IN PR added to
  the legend; section 10 V2 and implementation order updated; change log.
- Docs that name the live model now use CollectiveRoboticSystem /
  hasAutonomousParameters; walks and section 9/10 snapshots keep the old
  names where they record the v0.0.1 / v0.0.4 state.
- Deck: P7, refinements, and next-steps slides updated; regenerated from
  build_findings_deck.py (text diff vs the previous pptx = exactly these
  edits).
- README: points to PR #9 as pending on top of v0.0.4.

Refs hyssostech/C2SIMArtifacts#7, hyssostech/C2SIMArtifacts#8

Co-Authored-By: Claude Opus 5.5 <noreply@anthropic.com>
</commit_message>
<xml_diff>
--- a/Subgroups/ASX/InstantiationReview/ASX-Instantiation-Findings.pptx
+++ b/Subgroups/ASX/InstantiationReview/ASX-Instantiation-Findings.pptx
@@ -689,7 +689,7 @@
           </a:p>
           <a:p>
             <a:r>
-              <a:t>Decided by the sub-group: derive the collective/Swarm from CollectiveEntity. Current state: v0.0.3 dropped the Swarm class and v0.0.4 leaves CollecticeRoboticSystem (the typo is in the model - O1, now also in the XSD) under PhysicalEntity - so this is the first thing to apply, and the cheapest: one re-parenting axiom plus the spelling fix. Membership and command relations already exist, so the residual swarm work after that is small (Q-J).</a:t>
+              <a:t>Decided by the sub-group: derive the collective/Swarm from CollectiveEntity. Current state: v0.0.3 dropped the Swarm class and v0.0.4 leaves the collective class under PhysicalEntity (its O1 misspelling is fixed in PR #9) - so this is the first thing to apply, and the cheapest: one re-parenting axiom. Membership and command relations already exist, so the residual swarm work after that is small (Q-J).</a:t>
             </a:r>
           </a:p>
         </p:txBody>
@@ -1304,7 +1304,7 @@
           </a:p>
           <a:p>
             <a:r>
-              <a:t>The same decisions, grouped by commitment level: safe corrections (typos, the UUIDBase slip) are unambiguous; the structural decisions are now made and need applying in the OWL; content types need design. Nothing has been applied to the model or the workbooks by this review - the structural items are the group's decisions, the rest are proposals pending buy-in.</a:t>
+              <a:t>The same decisions, grouped by commitment level: safe corrections (typos, the UUIDBase slip) are unambiguous; the structural decisions are now made and need applying in the OWL; content types need design. Apart from the typo fixes (PR #9, pending merge), nothing has been applied to the model or the workbooks by this review - the structural items are the group's decisions, the rest are proposals pending buy-in.</a:t>
             </a:r>
           </a:p>
           <a:p>
@@ -1454,7 +1454,7 @@
           <a:lstStyle/>
           <a:p>
             <a:r>
-              <a:t>The recommended order now that the structural decisions are made: apply P7 (cheapest, one axiom), apply P1 (retire the Robot tree and home the new properties), run the sensor survey, fix the typos and finish the attribute layer, then re-cut the Initialization tabs and add the two CASEVAC content types; optionally adopt the diff-able workbooks so message edits can be reviewed in git.</a:t>
+              <a:t>The recommended order now that the structural decisions are made: apply P7 (cheapest, one axiom), apply P1 (retire the Robot tree and home the new properties), run the sensor survey, merge the typo fixes (PR #9) and finish the attribute layer, then re-cut the Initialization tabs and add the two CASEVAC content types; optionally adopt the diff-able workbooks so message edits can be reviewed in git.</a:t>
             </a:r>
           </a:p>
           <a:p>
@@ -6388,7 +6388,7 @@
                 </a:solidFill>
                 <a:latin typeface="Calibri"/>
               </a:rPr>
-              <a:t>CollecticeRoboticSystem (sic)</a:t>
+              <a:t>CollectiveRoboticSystem</a:t>
             </a:r>
           </a:p>
         </p:txBody>
@@ -6921,7 +6921,7 @@
                 </a:solidFill>
                 <a:latin typeface="Calibri"/>
               </a:rPr>
-              <a:t>not yet applied - no Swarm class (dropped in v0.0.3); CollecticeRoboticSystem (sic) still under RoboticSystem -&gt; Device -&gt; Artifact -&gt; PhysicalEntity, and now also in the derived XSD.</a:t>
+              <a:t>not yet applied - no Swarm class (dropped in v0.0.3); the collective class is still under RoboticSystem -&gt; Device -&gt; Artifact -&gt; PhysicalEntity (its O1 misspelling is fixed in PR #9).</a:t>
             </a:r>
           </a:p>
           <a:p>
@@ -6949,7 +6949,7 @@
                 </a:solidFill>
                 <a:latin typeface="Calibri"/>
               </a:rPr>
-              <a:t>re-parent (and re-spell, O1) the collective class under CollectiveEntity - one axiom - then the small residuals (Q-J: network params, leader role, aggregation Z1, lifecycle Z2); mixed membership (P10) becomes hasSubordinate over Platform subtypes.</a:t>
+              <a:t>re-parent the collective class under CollectiveEntity - one axiom - then the small residuals (Q-J: network params, leader role, aggregation Z1, lifecycle Z2); mixed membership (P10) becomes hasSubordinate over Platform subtypes.</a:t>
             </a:r>
           </a:p>
         </p:txBody>
@@ -10353,7 +10353,7 @@
                 </a:solidFill>
                 <a:latin typeface="Calibri"/>
               </a:rPr>
-              <a:t>Pending group buy-in - nothing applied to the model</a:t>
+              <a:t>Pending group buy-in - only the typo fixes are written (PR #9)</a:t>
             </a:r>
           </a:p>
         </p:txBody>
@@ -10404,7 +10404,7 @@
                 </a:solidFill>
                 <a:latin typeface="Calibri"/>
               </a:rPr>
-              <a:t>class typo CollecticeRoboticSystem -&gt; CollectiveRoboticSystem (O1); versionInfo Extrension -&gt; Extension (O2); file CSIM_ASX -&gt; C2SIM_ASX (O3); hasStartTime UUIDBase -&gt; TimeInstant (M7); unify namespace label ASX / C2SIM_ASX (M8).</a:t>
+              <a:t>typos fixed in PR #9 - CollectiveRoboticSystem (O1), hasAutonomousParameters (O4), versionInfo (O5), Operator comment (O6), pointer to the live file (O3); O2 already gone in v0.0.4. Still to apply: hasStartTime UUIDBase -&gt; TimeInstant (M7); unify namespace label ASX / C2SIM_ASX (M8).</a:t>
             </a:r>
           </a:p>
           <a:p>
@@ -10432,7 +10432,7 @@
                 </a:solidFill>
                 <a:latin typeface="Calibri"/>
               </a:rPr>
-              <a:t>autonomy as a facet on the Platform subtree, Robot tree retired (Q-A); collective -&gt; CollectiveEntity (Q-B); sensors reworked on existing standards (Q-C); state the one autonomy vocabulary (Q-D). Plus the new v0.0.4 typos (hasAutonomusParameters O4, versionInfo O5, Operator comment O6) and the four floating properties (V2).</a:t>
+              <a:t>autonomy as a facet on the Platform subtree, Robot tree retired (Q-A); collective -&gt; CollectiveEntity (Q-B); sensors reworked on existing standards (Q-C); state the one autonomy vocabulary (Q-D). Plus the four floating properties (V2).</a:t>
             </a:r>
           </a:p>
           <a:p>
@@ -10479,7 +10479,7 @@
                 </a:solidFill>
                 <a:latin typeface="Calibri"/>
               </a:rPr>
-              <a:t>•  Nothing here is applied to the model - all items are proposals for group buy-in.</a:t>
+              <a:t>•  Only the typo fixes are written (PR #9, pending merge into michael_d); everything else is a proposal for group buy-in.</a:t>
             </a:r>
           </a:p>
         </p:txBody>
@@ -11160,7 +11160,7 @@
                 </a:solidFill>
                 <a:latin typeface="Calibri"/>
               </a:rPr>
-              <a:t>•  Apply P7 in the OWL: re-parent (and re-spell) the collective class under CollectiveEntity - one axiom.</a:t>
+              <a:t>•  Apply P7 in the OWL: re-parent the collective class under CollectiveEntity - one axiom (its re-spelling is in PR #9).</a:t>
             </a:r>
           </a:p>
           <a:p>
@@ -11217,7 +11217,7 @@
                 </a:solidFill>
                 <a:latin typeface="Calibri"/>
               </a:rPr>
-              <a:t>•  Fix the typos while the classes are open (O1, O4, O5, O6); finish the attribute layer still marked x in the Concept Mapping (Payload, Mobility, Swarm Parameters).</a:t>
+              <a:t>•  Merge the typo fixes (PR #9: O1, O4, O5, O6); finish the attribute layer still marked x in the Concept Mapping (Payload, Mobility, Swarm Parameters).</a:t>
             </a:r>
           </a:p>
           <a:p>

</xml_diff>

<commit_message>
ASX review: typo fixes merged (PR #9) - O1 / O3-O6 / P9 resolved
Log statuses FIXED IN PR -> RESOLVED; O3 records the removal of the stale
derived schema; "pending merge" wording in the briefing, README and deck
updated; deck next steps drop the merge step. Deck regenerated.

Refs hyssostech/C2SIMArtifacts#7, hyssostech/C2SIMArtifacts#8

Co-Authored-By: Claude Opus 5.5 <noreply@anthropic.com>
</commit_message>
<xml_diff>
--- a/Subgroups/ASX/InstantiationReview/ASX-Instantiation-Findings.pptx
+++ b/Subgroups/ASX/InstantiationReview/ASX-Instantiation-Findings.pptx
@@ -1304,7 +1304,7 @@
           </a:p>
           <a:p>
             <a:r>
-              <a:t>The same decisions, grouped by commitment level: safe corrections (typos, the UUIDBase slip) are unambiguous; the structural decisions are now made and need applying in the OWL; content types need design. Apart from the typo fixes (PR #9, pending merge), nothing has been applied to the model or the workbooks by this review - the structural items are the group's decisions, the rest are proposals pending buy-in.</a:t>
+              <a:t>The same decisions, grouped by commitment level: safe corrections (typos, the UUIDBase slip) are unambiguous; the structural decisions are now made and need applying in the OWL; content types need design. Apart from the typo fixes (PR #9, merged), nothing has been applied to the model or the workbooks by this review - the structural items are the group's decisions, the rest are proposals pending buy-in.</a:t>
             </a:r>
           </a:p>
           <a:p>
@@ -1454,7 +1454,7 @@
           <a:lstStyle/>
           <a:p>
             <a:r>
-              <a:t>The recommended order now that the structural decisions are made: apply P7 (cheapest, one axiom), apply P1 (retire the Robot tree and home the new properties), run the sensor survey, merge the typo fixes (PR #9) and finish the attribute layer, then re-cut the Initialization tabs and add the two CASEVAC content types; optionally adopt the diff-able workbooks so message edits can be reviewed in git.</a:t>
+              <a:t>The recommended order now that the structural decisions are made: apply P7 (cheapest, one axiom), apply P1 (retire the Robot tree and home the new properties), run the sensor survey, finish the attribute layer, then re-cut the Initialization tabs and add the two CASEVAC content types; optionally adopt the diff-able workbooks so message edits can be reviewed in git.</a:t>
             </a:r>
           </a:p>
           <a:p>
@@ -10353,7 +10353,7 @@
                 </a:solidFill>
                 <a:latin typeface="Calibri"/>
               </a:rPr>
-              <a:t>Pending group buy-in - only the typo fixes are written (PR #9)</a:t>
+              <a:t>Pending group buy-in - only the typo fixes are applied (PR #9)</a:t>
             </a:r>
           </a:p>
         </p:txBody>
@@ -10479,7 +10479,7 @@
                 </a:solidFill>
                 <a:latin typeface="Calibri"/>
               </a:rPr>
-              <a:t>•  Only the typo fixes are written (PR #9, pending merge into main); everything else is a proposal for group buy-in.</a:t>
+              <a:t>•  Only the typo fixes are applied (PR #9, merged into main); everything else is a proposal for group buy-in.</a:t>
             </a:r>
           </a:p>
         </p:txBody>
@@ -11217,7 +11217,7 @@
                 </a:solidFill>
                 <a:latin typeface="Calibri"/>
               </a:rPr>
-              <a:t>•  Merge the typo fixes (PR #9: O1, O4, O5, O6); finish the attribute layer still marked x in the Concept Mapping (Payload, Mobility, Swarm Parameters).</a:t>
+              <a:t>•  Finish the attribute layer still marked x in the Concept Mapping (Payload, Mobility, Swarm Parameters); the typo fixes (O1, O4-O6) are done (PR #9).</a:t>
             </a:r>
           </a:p>
           <a:p>

</xml_diff>